<commit_message>
add new function for decide the amount of withdraw
</commit_message>
<xml_diff>
--- a/411121307_report.pptx
+++ b/411121307_report.pptx
@@ -3481,9 +3481,62 @@
           <a:p>
             <a:pPr lvl="1"/>
             <a:r>
-              <a:rPr kumimoji="1" lang="zh-TW" altLang="en-US"/>
-              <a:t>當市場行情好時（程式預設）</a:t>
-            </a:r>
+              <a:rPr kumimoji="1" lang="zh-TW" altLang="en-US" dirty="0"/>
+              <a:t>當市場行情好時</a:t>
+            </a:r>
+            <a:r>
+              <a:rPr kumimoji="1" lang="en-US" altLang="zh-TW" dirty="0"/>
+              <a:t> (market &gt; 800 BULL)</a:t>
+            </a:r>
+            <a:r>
+              <a:rPr kumimoji="1" lang="zh-TW" altLang="en-US" dirty="0"/>
+              <a:t>，資金將</a:t>
+            </a:r>
+            <a:r>
+              <a:rPr kumimoji="1" lang="en-US" altLang="zh-TW" dirty="0"/>
+              <a:t>100%</a:t>
+            </a:r>
+            <a:r>
+              <a:rPr kumimoji="1" lang="zh-TW" altLang="en-US" dirty="0"/>
+              <a:t>存入虛擬貨幣中。</a:t>
+            </a:r>
+            <a:endParaRPr kumimoji="1" lang="en-US" altLang="zh-TW" dirty="0"/>
+          </a:p>
+          <a:p>
+            <a:pPr lvl="1"/>
+            <a:r>
+              <a:rPr kumimoji="1" lang="zh-TW" altLang="en-US" dirty="0"/>
+              <a:t>當市場保守時</a:t>
+            </a:r>
+            <a:r>
+              <a:rPr kumimoji="1" lang="en-US" altLang="zh-TW" dirty="0"/>
+              <a:t> ( 501 &lt; market &lt; 799</a:t>
+            </a:r>
+            <a:r>
+              <a:rPr kumimoji="1" lang="zh-TW" altLang="en-US" dirty="0"/>
+              <a:t> </a:t>
+            </a:r>
+            <a:r>
+              <a:rPr kumimoji="1" lang="en-US" altLang="zh-TW" dirty="0"/>
+              <a:t>BEAR )</a:t>
+            </a:r>
+            <a:r>
+              <a:rPr kumimoji="1" lang="zh-TW" altLang="en-US" dirty="0"/>
+              <a:t>，資金將</a:t>
+            </a:r>
+            <a:r>
+              <a:rPr kumimoji="1" lang="en-US" altLang="zh-TW" dirty="0"/>
+              <a:t>80%</a:t>
+            </a:r>
+            <a:r>
+              <a:rPr kumimoji="1" lang="zh-TW" altLang="en-US" dirty="0"/>
+              <a:t>存入虛擬貨幣</a:t>
+            </a:r>
+            <a:r>
+              <a:rPr kumimoji="1" lang="zh-TW" altLang="en-US"/>
+              <a:t>中，避免</a:t>
+            </a:r>
+            <a:endParaRPr kumimoji="1" lang="en-US" altLang="zh-TW" dirty="0"/>
           </a:p>
         </p:txBody>
       </p:sp>

</xml_diff>